<commit_message>
Slides: shorten sd-09-001..005 copy to the ten-word budget, re-export PPTX
Co-Authored-By: Claude Opus 5.5 <noreply@anthropic.com>
Claude-Session: https://claude.ai/code/session_014EdyZwPF7XnU2uvEPKZ7Pf
</commit_message>
<xml_diff>
--- a/system-design-101/vi/lessons/sd-09-001/slides/sd-09-001.pptx
+++ b/system-design-101/vi/lessons/sd-09-001/slides/sd-09-001.pptx
@@ -5001,7 +5001,7 @@
               <a:buNone/>
             </a:pPr>
             <a:r>
-              <a:rPr lang="en-US" sz="1950" dirty="0" spc="-14" kern="0">
+              <a:rPr lang="en-US" sz="1950" dirty="0" spc="1" kern="0">
                 <a:solidFill>
                   <a:srgbClr val="6B6A66"/>
                 </a:solidFill>
@@ -5009,10 +5009,10 @@
                 <a:ea typeface="Be Vietnam Pro" pitchFamily="34" charset="-122"/>
                 <a:cs typeface="Be Vietnam Pro" pitchFamily="34" charset="-120"/>
               </a:rPr>
-              <a:t>Bắt</a:t>
-            </a:r>
-            <a:r>
-              <a:rPr lang="en-US" sz="1950" dirty="0" spc="8" kern="0">
+              <a:t>git</a:t>
+            </a:r>
+            <a:r>
+              <a:rPr lang="en-US" sz="1950" dirty="0" spc="0" kern="0">
                 <a:solidFill>
                   <a:srgbClr val="6B6A66"/>
                 </a:solidFill>
@@ -5020,7 +5020,18 @@
                 <a:ea typeface="Be Vietnam Pro" pitchFamily="34" charset="-122"/>
                 <a:cs typeface="Be Vietnam Pro" pitchFamily="34" charset="-120"/>
               </a:rPr>
-              <a:t> đầu:</a:t>
+              <a:t> init:</a:t>
+            </a:r>
+            <a:r>
+              <a:rPr lang="en-US" sz="1950" dirty="0" spc="-1" kern="0">
+                <a:solidFill>
+                  <a:srgbClr val="6B6A66"/>
+                </a:solidFill>
+                <a:latin typeface="Be Vietnam Pro" pitchFamily="34" charset="0"/>
+                <a:ea typeface="Be Vietnam Pro" pitchFamily="34" charset="-122"/>
+                <a:cs typeface="Be Vietnam Pro" pitchFamily="34" charset="-120"/>
+              </a:rPr>
+              <a:t> kho mới.</a:t>
             </a:r>
             <a:r>
               <a:rPr lang="en-US" sz="1950" dirty="0" spc="0" kern="0">
@@ -5031,10 +5042,10 @@
                 <a:ea typeface="Be Vietnam Pro" pitchFamily="34" charset="-122"/>
                 <a:cs typeface="Be Vietnam Pro" pitchFamily="34" charset="-120"/>
               </a:rPr>
-              <a:t> git</a:t>
-            </a:r>
-            <a:r>
-              <a:rPr lang="en-US" sz="1950" dirty="0" spc="1" kern="0">
+              <a:t> git clone:</a:t>
+            </a:r>
+            <a:r>
+              <a:rPr lang="en-US" sz="1950" dirty="0" spc="-1" kern="0">
                 <a:solidFill>
                   <a:srgbClr val="6B6A66"/>
                 </a:solidFill>
@@ -5042,10 +5053,10 @@
                 <a:ea typeface="Be Vietnam Pro" pitchFamily="34" charset="-122"/>
                 <a:cs typeface="Be Vietnam Pro" pitchFamily="34" charset="-120"/>
               </a:rPr>
-              <a:t> init</a:t>
-            </a:r>
-            <a:r>
-              <a:rPr lang="en-US" sz="1950" dirty="0" spc="-11" kern="0">
+              <a:t> kho</a:t>
+            </a:r>
+            <a:r>
+              <a:rPr lang="en-US" sz="1950" dirty="0" spc="-4" kern="0">
                 <a:solidFill>
                   <a:srgbClr val="6B6A66"/>
                 </a:solidFill>
@@ -5053,95 +5064,7 @@
                 <a:ea typeface="Be Vietnam Pro" pitchFamily="34" charset="-122"/>
                 <a:cs typeface="Be Vietnam Pro" pitchFamily="34" charset="-120"/>
               </a:rPr>
-              <a:t> tạo</a:t>
-            </a:r>
-            <a:r>
-              <a:rPr lang="en-US" sz="1950" dirty="0" spc="-1" kern="0">
-                <a:solidFill>
-                  <a:srgbClr val="6B6A66"/>
-                </a:solidFill>
-                <a:latin typeface="Be Vietnam Pro" pitchFamily="34" charset="0"/>
-                <a:ea typeface="Be Vietnam Pro" pitchFamily="34" charset="-122"/>
-                <a:cs typeface="Be Vietnam Pro" pitchFamily="34" charset="-120"/>
-              </a:rPr>
-              <a:t> kho</a:t>
-            </a:r>
-            <a:r>
-              <a:rPr lang="en-US" sz="1950" dirty="0" spc="1" kern="0">
-                <a:solidFill>
-                  <a:srgbClr val="6B6A66"/>
-                </a:solidFill>
-                <a:latin typeface="Be Vietnam Pro" pitchFamily="34" charset="0"/>
-                <a:ea typeface="Be Vietnam Pro" pitchFamily="34" charset="-122"/>
-                <a:cs typeface="Be Vietnam Pro" pitchFamily="34" charset="-120"/>
-              </a:rPr>
-              <a:t> mới,</a:t>
-            </a:r>
-            <a:r>
-              <a:rPr lang="en-US" sz="1950" dirty="0" spc="0" kern="0">
-                <a:solidFill>
-                  <a:srgbClr val="6B6A66"/>
-                </a:solidFill>
-                <a:latin typeface="Be Vietnam Pro" pitchFamily="34" charset="0"/>
-                <a:ea typeface="Be Vietnam Pro" pitchFamily="34" charset="-122"/>
-                <a:cs typeface="Be Vietnam Pro" pitchFamily="34" charset="-120"/>
-              </a:rPr>
-              <a:t> git</a:t>
-            </a:r>
-            <a:r>
-              <a:rPr lang="en-US" sz="1950" dirty="0" spc="1" kern="0">
-                <a:solidFill>
-                  <a:srgbClr val="6B6A66"/>
-                </a:solidFill>
-                <a:latin typeface="Be Vietnam Pro" pitchFamily="34" charset="0"/>
-                <a:ea typeface="Be Vietnam Pro" pitchFamily="34" charset="-122"/>
-                <a:cs typeface="Be Vietnam Pro" pitchFamily="34" charset="-120"/>
-              </a:rPr>
-              <a:t> clone</a:t>
-            </a:r>
-            <a:r>
-              <a:rPr lang="en-US" sz="1950" dirty="0" spc="-9" kern="0">
-                <a:solidFill>
-                  <a:srgbClr val="6B6A66"/>
-                </a:solidFill>
-                <a:latin typeface="Be Vietnam Pro" pitchFamily="34" charset="0"/>
-                <a:ea typeface="Be Vietnam Pro" pitchFamily="34" charset="-122"/>
-                <a:cs typeface="Be Vietnam Pro" pitchFamily="34" charset="-120"/>
-              </a:rPr>
-              <a:t> lấy</a:t>
-            </a:r>
-            <a:r>
-              <a:rPr lang="en-US" sz="1950" dirty="0" spc="-2" kern="0">
-                <a:solidFill>
-                  <a:srgbClr val="6B6A66"/>
-                </a:solidFill>
-                <a:latin typeface="Be Vietnam Pro" pitchFamily="34" charset="0"/>
-                <a:ea typeface="Be Vietnam Pro" pitchFamily="34" charset="-122"/>
-                <a:cs typeface="Be Vietnam Pro" pitchFamily="34" charset="-120"/>
-              </a:rPr>
-              <a:t> kho</a:t>
-            </a:r>
-            <a:r>
-              <a:rPr lang="en-US" sz="1950" dirty="0" spc="-3" kern="0">
-                <a:solidFill>
-                  <a:srgbClr val="6B6A66"/>
-                </a:solidFill>
-                <a:latin typeface="Be Vietnam Pro" pitchFamily="34" charset="0"/>
-                <a:ea typeface="Be Vietnam Pro" pitchFamily="34" charset="-122"/>
-                <a:cs typeface="Be Vietnam Pro" pitchFamily="34" charset="-120"/>
-              </a:rPr>
-              <a:t> có</a:t>
-            </a:r>
-            <a:r>
-              <a:rPr lang="en-US" sz="1950" dirty="0" spc="-4" kern="0">
-                <a:solidFill>
-                  <a:srgbClr val="6B6A66"/>
-                </a:solidFill>
-                <a:latin typeface="Be Vietnam Pro" pitchFamily="34" charset="0"/>
-                <a:ea typeface="Be Vietnam Pro" pitchFamily="34" charset="-122"/>
-                <a:cs typeface="Be Vietnam Pro" pitchFamily="34" charset="-120"/>
-              </a:rPr>
-              <a:t> sẵn.</a:t>
+              <a:t> có sẵn.</a:t>
             </a:r>
             <a:endParaRPr lang="en-US" sz="1950" dirty="0"/>
           </a:p>
@@ -8457,40 +8380,7 @@
               <a:t> mốc</a:t>
             </a:r>
             <a:r>
-              <a:rPr lang="en-US" sz="2700" dirty="0" spc="-20" kern="0">
-                <a:solidFill>
-                  <a:srgbClr val="6B6A66"/>
-                </a:solidFill>
-                <a:latin typeface="Be Vietnam Pro" pitchFamily="34" charset="0"/>
-                <a:ea typeface="Be Vietnam Pro" pitchFamily="34" charset="-122"/>
-                <a:cs typeface="Be Vietnam Pro" pitchFamily="34" charset="-120"/>
-              </a:rPr>
-              <a:t> trong</a:t>
-            </a:r>
-            <a:r>
-              <a:rPr lang="en-US" sz="2700" dirty="0" spc="-1" kern="0">
-                <a:solidFill>
-                  <a:srgbClr val="6B6A66"/>
-                </a:solidFill>
-                <a:latin typeface="Be Vietnam Pro" pitchFamily="34" charset="0"/>
-                <a:ea typeface="Be Vietnam Pro" pitchFamily="34" charset="-122"/>
-                <a:cs typeface="Be Vietnam Pro" pitchFamily="34" charset="-120"/>
-              </a:rPr>
-              <a:t> lịch</a:t>
-            </a:r>
-            <a:r>
-              <a:rPr lang="en-US" sz="2700" dirty="0" spc="-4" kern="0">
-                <a:solidFill>
-                  <a:srgbClr val="6B6A66"/>
-                </a:solidFill>
-                <a:latin typeface="Be Vietnam Pro" pitchFamily="34" charset="0"/>
-                <a:ea typeface="Be Vietnam Pro" pitchFamily="34" charset="-122"/>
-                <a:cs typeface="Be Vietnam Pro" pitchFamily="34" charset="-120"/>
-              </a:rPr>
-              <a:t> sử</a:t>
-            </a:r>
-            <a:r>
-              <a:rPr lang="en-US" sz="2700" dirty="0" spc="15" kern="0">
+              <a:rPr lang="en-US" sz="2700" dirty="0" spc="14" kern="0">
                 <a:solidFill>
                   <a:srgbClr val="6B6A66"/>
                 </a:solidFill>
@@ -13293,7 +13183,7 @@
               <a:buNone/>
             </a:pPr>
             <a:r>
-              <a:rPr lang="en-US" sz="2700" dirty="0" spc="1" kern="0">
+              <a:rPr lang="en-US" sz="2700" dirty="0" spc="-7" kern="0">
                 <a:solidFill>
                   <a:srgbClr val="14161C"/>
                 </a:solidFill>
@@ -13301,10 +13191,10 @@
                 <a:ea typeface="Be Vietnam Pro" pitchFamily="34" charset="-122"/>
                 <a:cs typeface="Be Vietnam Pro" pitchFamily="34" charset="-120"/>
               </a:rPr>
-              <a:t>Commit</a:t>
-            </a:r>
-            <a:r>
-              <a:rPr lang="en-US" sz="2700" dirty="0" spc="-1" kern="0">
+              <a:t>Một</a:t>
+            </a:r>
+            <a:r>
+              <a:rPr lang="en-US" sz="2700" dirty="0" spc="-4" kern="0">
                 <a:solidFill>
                   <a:srgbClr val="14161C"/>
                 </a:solidFill>
@@ -13312,10 +13202,10 @@
                 <a:ea typeface="Be Vietnam Pro" pitchFamily="34" charset="-122"/>
                 <a:cs typeface="Be Vietnam Pro" pitchFamily="34" charset="-120"/>
               </a:rPr>
-              <a:t> là</a:t>
-            </a:r>
-            <a:r>
-              <a:rPr lang="en-US" sz="2700" dirty="0" spc="-8" kern="0">
+              <a:t> mốc</a:t>
+            </a:r>
+            <a:r>
+              <a:rPr lang="en-US" sz="2700" dirty="0" spc="15" kern="0">
                 <a:solidFill>
                   <a:srgbClr val="14161C"/>
                 </a:solidFill>
@@ -13323,10 +13213,10 @@
                 <a:ea typeface="Be Vietnam Pro" pitchFamily="34" charset="-122"/>
                 <a:cs typeface="Be Vietnam Pro" pitchFamily="34" charset="-120"/>
               </a:rPr>
-              <a:t> một</a:t>
-            </a:r>
-            <a:r>
-              <a:rPr lang="en-US" sz="2700" dirty="0" spc="-4" kern="0">
+              <a:t> để</a:t>
+            </a:r>
+            <a:r>
+              <a:rPr lang="en-US" sz="2700" dirty="0" spc="-13" kern="0">
                 <a:solidFill>
                   <a:srgbClr val="14161C"/>
                 </a:solidFill>
@@ -13334,10 +13224,10 @@
                 <a:ea typeface="Be Vietnam Pro" pitchFamily="34" charset="-122"/>
                 <a:cs typeface="Be Vietnam Pro" pitchFamily="34" charset="-120"/>
               </a:rPr>
-              <a:t> mốc</a:t>
-            </a:r>
-            <a:r>
-              <a:rPr lang="en-US" sz="2700" dirty="0" spc="15" kern="0">
+              <a:t> so</a:t>
+            </a:r>
+            <a:r>
+              <a:rPr lang="en-US" sz="2700" dirty="0" spc="-5" kern="0">
                 <a:solidFill>
                   <a:srgbClr val="14161C"/>
                 </a:solidFill>
@@ -13345,10 +13235,10 @@
                 <a:ea typeface="Be Vietnam Pro" pitchFamily="34" charset="-122"/>
                 <a:cs typeface="Be Vietnam Pro" pitchFamily="34" charset="-120"/>
               </a:rPr>
-              <a:t> để</a:t>
-            </a:r>
-            <a:r>
-              <a:rPr lang="en-US" sz="2700" dirty="0" spc="-12" kern="0">
+              <a:t> sánh,</a:t>
+            </a:r>
+            <a:r>
+              <a:rPr lang="en-US" sz="2700" dirty="0" spc="-2" kern="0">
                 <a:solidFill>
                   <a:srgbClr val="14161C"/>
                 </a:solidFill>
@@ -13356,10 +13246,10 @@
                 <a:ea typeface="Be Vietnam Pro" pitchFamily="34" charset="-122"/>
                 <a:cs typeface="Be Vietnam Pro" pitchFamily="34" charset="-120"/>
               </a:rPr>
-              <a:t> so</a:t>
-            </a:r>
-            <a:r>
-              <a:rPr lang="en-US" sz="2700" dirty="0" spc="-6" kern="0">
+              <a:t> không</a:t>
+            </a:r>
+            <a:r>
+              <a:rPr lang="en-US" sz="2700" dirty="0" spc="-11" kern="0">
                 <a:solidFill>
                   <a:srgbClr val="14161C"/>
                 </a:solidFill>
@@ -13367,7 +13257,7 @@
                 <a:ea typeface="Be Vietnam Pro" pitchFamily="34" charset="-122"/>
                 <a:cs typeface="Be Vietnam Pro" pitchFamily="34" charset="-120"/>
               </a:rPr>
-              <a:t> sánh,</a:t>
+              <a:t> sao</a:t>
             </a:r>
             <a:r>
               <a:rPr lang="en-US" sz="2700" dirty="0" spc="-2" kern="0">
@@ -13378,10 +13268,10 @@
                 <a:ea typeface="Be Vietnam Pro" pitchFamily="34" charset="-122"/>
                 <a:cs typeface="Be Vietnam Pro" pitchFamily="34" charset="-120"/>
               </a:rPr>
-              <a:t> không</a:t>
-            </a:r>
-            <a:r>
-              <a:rPr lang="en-US" sz="2700" dirty="0" spc="0" kern="0">
+              <a:t> mọi</a:t>
+            </a:r>
+            <a:r>
+              <a:rPr lang="en-US" sz="2700" dirty="0" spc="3" kern="0">
                 <a:solidFill>
                   <a:srgbClr val="14161C"/>
                 </a:solidFill>
@@ -13389,62 +13279,7 @@
                 <a:ea typeface="Be Vietnam Pro" pitchFamily="34" charset="-122"/>
                 <a:cs typeface="Be Vietnam Pro" pitchFamily="34" charset="-120"/>
               </a:rPr>
-              <a:t> tự</a:t>
-            </a:r>
-            <a:r>
-              <a:rPr lang="en-US" sz="2700" dirty="0" spc="-11" kern="0">
-                <a:solidFill>
-                  <a:srgbClr val="14161C"/>
-                </a:solidFill>
-                <a:latin typeface="Be Vietnam Pro" pitchFamily="34" charset="0"/>
-                <a:ea typeface="Be Vietnam Pro" pitchFamily="34" charset="-122"/>
-                <a:cs typeface="Be Vietnam Pro" pitchFamily="34" charset="-120"/>
-              </a:rPr>
-              <a:t> sao</a:t>
-            </a:r>
-            <a:r>
-              <a:rPr lang="en-US" sz="2700" dirty="0" spc="-2" kern="0">
-                <a:solidFill>
-                  <a:srgbClr val="14161C"/>
-                </a:solidFill>
-                <a:latin typeface="Be Vietnam Pro" pitchFamily="34" charset="0"/>
-                <a:ea typeface="Be Vietnam Pro" pitchFamily="34" charset="-122"/>
-                <a:cs typeface="Be Vietnam Pro" pitchFamily="34" charset="-120"/>
-              </a:rPr>
-              <a:t> mọi</a:t>
-            </a:r>
-            <a:r>
-              <a:rPr lang="en-US" sz="2700" dirty="0" spc="5" kern="0">
-                <a:solidFill>
-                  <a:srgbClr val="14161C"/>
-                </a:solidFill>
-                <a:latin typeface="Be Vietnam Pro" pitchFamily="34" charset="0"/>
-                <a:ea typeface="Be Vietnam Pro" pitchFamily="34" charset="-122"/>
-                <a:cs typeface="Be Vietnam Pro" pitchFamily="34" charset="-120"/>
-              </a:rPr>
-              <a:t> file</a:t>
-            </a:r>
-            <a:r>
-              <a:rPr lang="en-US" sz="2700" dirty="0" spc="-24" kern="0">
-                <a:solidFill>
-                  <a:srgbClr val="14161C"/>
-                </a:solidFill>
-                <a:latin typeface="Be Vietnam Pro" pitchFamily="34" charset="0"/>
-                <a:ea typeface="Be Vietnam Pro" pitchFamily="34" charset="-122"/>
-                <a:cs typeface="Be Vietnam Pro" pitchFamily="34" charset="-120"/>
-              </a:rPr>
-              <a:t> trên</a:t>
-            </a:r>
-            <a:r>
-              <a:rPr lang="en-US" sz="2700" dirty="0" spc="-10" kern="0">
-                <a:solidFill>
-                  <a:srgbClr val="14161C"/>
-                </a:solidFill>
-                <a:latin typeface="Be Vietnam Pro" pitchFamily="34" charset="0"/>
-                <a:ea typeface="Be Vietnam Pro" pitchFamily="34" charset="-122"/>
-                <a:cs typeface="Be Vietnam Pro" pitchFamily="34" charset="-120"/>
-              </a:rPr>
-              <a:t> máy.</a:t>
+              <a:t> file.</a:t>
             </a:r>
             <a:endParaRPr lang="en-US" sz="2700" dirty="0"/>
           </a:p>
@@ -13735,7 +13570,7 @@
               <a:t>Không</a:t>
             </a:r>
             <a:r>
-              <a:rPr lang="en-US" sz="2700" dirty="0" spc="-1" kern="0">
+              <a:rPr lang="en-US" sz="2700" dirty="0" spc="-27" kern="0">
                 <a:solidFill>
                   <a:srgbClr val="F3EEE3"/>
                 </a:solidFill>
@@ -13743,7 +13578,7 @@
                 <a:ea typeface="Be Vietnam Pro" pitchFamily="34" charset="-122"/>
                 <a:cs typeface="Be Vietnam Pro" pitchFamily="34" charset="-120"/>
               </a:rPr>
-              <a:t> làm</a:t>
+              <a:t> xóa</a:t>
             </a:r>
             <a:r>
               <a:rPr lang="en-US" sz="2700" dirty="0" spc="4" kern="0">
@@ -13776,40 +13611,7 @@
                 <a:ea typeface="Be Vietnam Pro" pitchFamily="34" charset="-122"/>
                 <a:cs typeface="Be Vietnam Pro" pitchFamily="34" charset="-120"/>
               </a:rPr>
-              <a:t> theo dõi</a:t>
-            </a:r>
-            <a:r>
-              <a:rPr lang="en-US" sz="2700" dirty="0" spc="-3" kern="0">
-                <a:solidFill>
-                  <a:srgbClr val="F3EEE3"/>
-                </a:solidFill>
-                <a:latin typeface="Be Vietnam Pro" pitchFamily="34" charset="0"/>
-                <a:ea typeface="Be Vietnam Pro" pitchFamily="34" charset="-122"/>
-                <a:cs typeface="Be Vietnam Pro" pitchFamily="34" charset="-120"/>
-              </a:rPr>
-              <a:t> biến</a:t>
-            </a:r>
-            <a:r>
-              <a:rPr lang="en-US" sz="2700" dirty="0" spc="-13" kern="0">
-                <a:solidFill>
-                  <a:srgbClr val="F3EEE3"/>
-                </a:solidFill>
-                <a:latin typeface="Be Vietnam Pro" pitchFamily="34" charset="0"/>
-                <a:ea typeface="Be Vietnam Pro" pitchFamily="34" charset="-122"/>
-                <a:cs typeface="Be Vietnam Pro" pitchFamily="34" charset="-120"/>
-              </a:rPr>
-              <a:t> mất</a:t>
-            </a:r>
-            <a:r>
-              <a:rPr lang="en-US" sz="2700" dirty="0" spc="-2" kern="0">
-                <a:solidFill>
-                  <a:srgbClr val="F3EEE3"/>
-                </a:solidFill>
-                <a:latin typeface="Be Vietnam Pro" pitchFamily="34" charset="0"/>
-                <a:ea typeface="Be Vietnam Pro" pitchFamily="34" charset="-122"/>
-                <a:cs typeface="Be Vietnam Pro" pitchFamily="34" charset="-120"/>
-              </a:rPr>
-              <a:t> khỏi</a:t>
+              <a:t> theo dõi khỏi</a:t>
             </a:r>
             <a:r>
               <a:rPr lang="en-US" sz="2700" dirty="0" spc="-1" kern="0">

</xml_diff>

<commit_message>
Slides: complete the branch line of sd-09-001, re-export PPTX
Co-Authored-By: Claude Opus 5.5 <noreply@anthropic.com>
Claude-Session: https://claude.ai/code/session_014EdyZwPF7XnU2uvEPKZ7Pf
</commit_message>
<xml_diff>
--- a/system-design-101/vi/lessons/sd-09-001/slides/sd-09-001.pptx
+++ b/system-design-101/vi/lessons/sd-09-001/slides/sd-09-001.pptx
@@ -8445,7 +8445,7 @@
               <a:buNone/>
             </a:pPr>
             <a:r>
-              <a:rPr lang="en-US" sz="2250" b="1" dirty="0" spc="0" kern="0">
+              <a:rPr lang="en-US" sz="2250" b="1" dirty="0" spc="-1" kern="0">
                 <a:solidFill>
                   <a:srgbClr val="E8472B"/>
                 </a:solidFill>
@@ -8453,7 +8453,40 @@
                 <a:ea typeface="Be Vietnam Pro" pitchFamily="34" charset="-122"/>
                 <a:cs typeface="Be Vietnam Pro" pitchFamily="34" charset="-120"/>
               </a:rPr>
-              <a:t>Nhánh</a:t>
+              <a:t>git</a:t>
+            </a:r>
+            <a:r>
+              <a:rPr lang="en-US" sz="2250" b="1" dirty="0" spc="-7" kern="0">
+                <a:solidFill>
+                  <a:srgbClr val="E8472B"/>
+                </a:solidFill>
+                <a:latin typeface="Be Vietnam Pro" pitchFamily="34" charset="0"/>
+                <a:ea typeface="Be Vietnam Pro" pitchFamily="34" charset="-122"/>
+                <a:cs typeface="Be Vietnam Pro" pitchFamily="34" charset="-120"/>
+              </a:rPr>
+              <a:t> switch</a:t>
+            </a:r>
+            <a:r>
+              <a:rPr lang="en-US" sz="2250" b="1" dirty="0" spc="3" kern="0">
+                <a:solidFill>
+                  <a:srgbClr val="E8472B"/>
+                </a:solidFill>
+                <a:latin typeface="Be Vietnam Pro" pitchFamily="34" charset="0"/>
+                <a:ea typeface="Be Vietnam Pro" pitchFamily="34" charset="-122"/>
+                <a:cs typeface="Be Vietnam Pro" pitchFamily="34" charset="-120"/>
+              </a:rPr>
+              <a:t> -c</a:t>
+            </a:r>
+            <a:r>
+              <a:rPr lang="en-US" sz="2250" b="1" dirty="0" spc="1" kern="0">
+                <a:solidFill>
+                  <a:srgbClr val="E8472B"/>
+                </a:solidFill>
+                <a:latin typeface="Be Vietnam Pro" pitchFamily="34" charset="0"/>
+                <a:ea typeface="Be Vietnam Pro" pitchFamily="34" charset="-122"/>
+                <a:cs typeface="Be Vietnam Pro" pitchFamily="34" charset="-120"/>
+              </a:rPr>
+              <a:t> fix-title:</a:t>
             </a:r>
             <a:r>
               <a:rPr lang="en-US" sz="2250" b="1" dirty="0" spc="2" kern="0">
@@ -8464,7 +8497,40 @@
                 <a:ea typeface="Be Vietnam Pro" pitchFamily="34" charset="-122"/>
                 <a:cs typeface="Be Vietnam Pro" pitchFamily="34" charset="-120"/>
               </a:rPr>
-              <a:t> riêng:</a:t>
+              <a:t> tạo</a:t>
+            </a:r>
+            <a:r>
+              <a:rPr lang="en-US" sz="2250" b="1" dirty="0" spc="-17" kern="0">
+                <a:solidFill>
+                  <a:srgbClr val="E8472B"/>
+                </a:solidFill>
+                <a:latin typeface="Be Vietnam Pro" pitchFamily="34" charset="0"/>
+                <a:ea typeface="Be Vietnam Pro" pitchFamily="34" charset="-122"/>
+                <a:cs typeface="Be Vietnam Pro" pitchFamily="34" charset="-120"/>
+              </a:rPr>
+              <a:t> và</a:t>
+            </a:r>
+            <a:r>
+              <a:rPr lang="en-US" sz="2250" b="1" dirty="0" spc="-10" kern="0">
+                <a:solidFill>
+                  <a:srgbClr val="E8472B"/>
+                </a:solidFill>
+                <a:latin typeface="Be Vietnam Pro" pitchFamily="34" charset="0"/>
+                <a:ea typeface="Be Vietnam Pro" pitchFamily="34" charset="-122"/>
+                <a:cs typeface="Be Vietnam Pro" pitchFamily="34" charset="-120"/>
+              </a:rPr>
+              <a:t> chuyển</a:t>
+            </a:r>
+            <a:r>
+              <a:rPr lang="en-US" sz="2250" b="1" dirty="0" spc="-4" kern="0">
+                <a:solidFill>
+                  <a:srgbClr val="E8472B"/>
+                </a:solidFill>
+                <a:latin typeface="Be Vietnam Pro" pitchFamily="34" charset="0"/>
+                <a:ea typeface="Be Vietnam Pro" pitchFamily="34" charset="-122"/>
+                <a:cs typeface="Be Vietnam Pro" pitchFamily="34" charset="-120"/>
+              </a:rPr>
+              <a:t> sang</a:t>
             </a:r>
             <a:r>
               <a:rPr lang="en-US" sz="2250" b="1" dirty="0" spc="1" kern="0">
@@ -8475,10 +8541,10 @@
                 <a:ea typeface="Be Vietnam Pro" pitchFamily="34" charset="-122"/>
                 <a:cs typeface="Be Vietnam Pro" pitchFamily="34" charset="-120"/>
               </a:rPr>
-              <a:t> git</a:t>
-            </a:r>
-            <a:r>
-              <a:rPr lang="en-US" sz="2250" b="1" dirty="0" spc="-7" kern="0">
+              <a:t> nhánh</a:t>
+            </a:r>
+            <a:r>
+              <a:rPr lang="en-US" sz="2250" b="1" dirty="0" spc="6" kern="0">
                 <a:solidFill>
                   <a:srgbClr val="E8472B"/>
                 </a:solidFill>
@@ -8486,73 +8552,7 @@
                 <a:ea typeface="Be Vietnam Pro" pitchFamily="34" charset="-122"/>
                 <a:cs typeface="Be Vietnam Pro" pitchFamily="34" charset="-120"/>
               </a:rPr>
-              <a:t> switch</a:t>
-            </a:r>
-            <a:r>
-              <a:rPr lang="en-US" sz="2250" b="1" dirty="0" spc="3" kern="0">
-                <a:solidFill>
-                  <a:srgbClr val="E8472B"/>
-                </a:solidFill>
-                <a:latin typeface="Be Vietnam Pro" pitchFamily="34" charset="0"/>
-                <a:ea typeface="Be Vietnam Pro" pitchFamily="34" charset="-122"/>
-                <a:cs typeface="Be Vietnam Pro" pitchFamily="34" charset="-120"/>
-              </a:rPr>
-              <a:t> -c</a:t>
-            </a:r>
-            <a:r>
-              <a:rPr lang="en-US" sz="2250" b="1" dirty="0" spc="0" kern="0">
-                <a:solidFill>
-                  <a:srgbClr val="E8472B"/>
-                </a:solidFill>
-                <a:latin typeface="Be Vietnam Pro" pitchFamily="34" charset="0"/>
-                <a:ea typeface="Be Vietnam Pro" pitchFamily="34" charset="-122"/>
-                <a:cs typeface="Be Vietnam Pro" pitchFamily="34" charset="-120"/>
-              </a:rPr>
-              <a:t> fix-title</a:t>
-            </a:r>
-            <a:r>
-              <a:rPr lang="en-US" sz="2250" b="1" dirty="0" spc="3" kern="0">
-                <a:solidFill>
-                  <a:srgbClr val="E8472B"/>
-                </a:solidFill>
-                <a:latin typeface="Be Vietnam Pro" pitchFamily="34" charset="0"/>
-                <a:ea typeface="Be Vietnam Pro" pitchFamily="34" charset="-122"/>
-                <a:cs typeface="Be Vietnam Pro" pitchFamily="34" charset="-120"/>
-              </a:rPr>
-              <a:t> tạo</a:t>
-            </a:r>
-            <a:r>
-              <a:rPr lang="en-US" sz="2250" b="1" dirty="0" spc="-16" kern="0">
-                <a:solidFill>
-                  <a:srgbClr val="E8472B"/>
-                </a:solidFill>
-                <a:latin typeface="Be Vietnam Pro" pitchFamily="34" charset="0"/>
-                <a:ea typeface="Be Vietnam Pro" pitchFamily="34" charset="-122"/>
-                <a:cs typeface="Be Vietnam Pro" pitchFamily="34" charset="-120"/>
-              </a:rPr>
-              <a:t> và</a:t>
-            </a:r>
-            <a:r>
-              <a:rPr lang="en-US" sz="2250" b="1" dirty="0" spc="-10" kern="0">
-                <a:solidFill>
-                  <a:srgbClr val="E8472B"/>
-                </a:solidFill>
-                <a:latin typeface="Be Vietnam Pro" pitchFamily="34" charset="0"/>
-                <a:ea typeface="Be Vietnam Pro" pitchFamily="34" charset="-122"/>
-                <a:cs typeface="Be Vietnam Pro" pitchFamily="34" charset="-120"/>
-              </a:rPr>
-              <a:t> chuyển</a:t>
-            </a:r>
-            <a:r>
-              <a:rPr lang="en-US" sz="2250" b="1" dirty="0" spc="-4" kern="0">
-                <a:solidFill>
-                  <a:srgbClr val="E8472B"/>
-                </a:solidFill>
-                <a:latin typeface="Be Vietnam Pro" pitchFamily="34" charset="0"/>
-                <a:ea typeface="Be Vietnam Pro" pitchFamily="34" charset="-122"/>
-                <a:cs typeface="Be Vietnam Pro" pitchFamily="34" charset="-120"/>
-              </a:rPr>
-              <a:t> sang</a:t>
+              <a:t> mới</a:t>
             </a:r>
             <a:endParaRPr lang="en-US" sz="2250" dirty="0"/>
           </a:p>

</xml_diff>